<commit_message>
docs(report): redesign figures and integrate case studies
</commit_message>
<xml_diff>
--- a/technical_report/figures/reviewer_mechanism.pptx
+++ b/technical_report/figures/reviewer_mechanism.pptx
@@ -7,7 +7,7 @@
   <p:sldIdLst>
     <p:sldId id="256" r:id="rId7"/>
   </p:sldIdLst>
-  <p:sldSz cx="10972800" cy="3063240" type="screen4x3"/>
+  <p:sldSz cx="10972800" cy="2423160" type="screen4x3"/>
   <p:notesSz cx="6858000" cy="9144000"/>
   <p:defaultTextStyle>
     <a:defPPr>
@@ -3084,7 +3084,7 @@
     <p:bg>
       <p:bgPr>
         <a:solidFill>
-          <a:srgbClr val="FFFFFF"/>
+          <a:srgbClr val="FBF7EE"/>
         </a:solidFill>
         <a:effectLst/>
       </p:bgPr>
@@ -3096,26 +3096,50 @@
         <p:nvPr/>
       </p:nvGrpSpPr>
       <p:grpSpPr/>
-      <p:sp>
-        <p:nvSpPr>
-          <p:cNvPr id="2" name="Rounded Rectangle 1"/>
+      <p:pic>
+        <p:nvPicPr>
+          <p:cNvPr id="2" name="Picture 1" descr="mountain_strip.png"/>
+          <p:cNvPicPr>
+            <a:picLocks noChangeAspect="1"/>
+          </p:cNvPicPr>
+          <p:nvPr/>
+        </p:nvPicPr>
+        <p:blipFill>
+          <a:blip r:embed="rId2"/>
+          <a:stretch>
+            <a:fillRect/>
+          </a:stretch>
+        </p:blipFill>
+        <p:spPr>
+          <a:xfrm>
+            <a:off x="0" y="2231136"/>
+            <a:ext cx="10972800" cy="192024"/>
+          </a:xfrm>
+          <a:prstGeom prst="rect">
+            <a:avLst/>
+          </a:prstGeom>
+        </p:spPr>
+      </p:pic>
+      <p:sp>
+        <p:nvSpPr>
+          <p:cNvPr id="3" name="Rounded Rectangle 2"/>
           <p:cNvSpPr/>
           <p:nvPr/>
         </p:nvSpPr>
         <p:spPr>
           <a:xfrm>
             <a:off x="0" y="0"/>
-            <a:ext cx="10972800" cy="45720"/>
+            <a:ext cx="10972800" cy="41148"/>
           </a:xfrm>
           <a:prstGeom prst="roundRect">
             <a:avLst/>
           </a:prstGeom>
           <a:solidFill>
-            <a:srgbClr val="315BCE"/>
+            <a:srgbClr val="24465D"/>
           </a:solidFill>
           <a:ln w="10160">
             <a:solidFill>
-              <a:srgbClr val="315BCE"/>
+              <a:srgbClr val="24465D"/>
             </a:solidFill>
           </a:ln>
           <a:effectLst/>
@@ -3144,90 +3168,20 @@
       </p:sp>
       <p:sp>
         <p:nvSpPr>
-          <p:cNvPr id="3" name="TextBox 2"/>
-          <p:cNvSpPr txBox="1"/>
-          <p:nvPr/>
-        </p:nvSpPr>
-        <p:spPr>
-          <a:xfrm>
-            <a:off x="320040" y="128016"/>
-            <a:ext cx="10241280" cy="310896"/>
-          </a:xfrm>
-          <a:prstGeom prst="rect">
-            <a:avLst/>
-          </a:prstGeom>
-          <a:noFill/>
-        </p:spPr>
-        <p:txBody>
-          <a:bodyPr wrap="none" lIns="18288" rIns="18288" tIns="9144" bIns="9144" anchor="ctr">
-            <a:spAutoFit/>
-          </a:bodyPr>
-          <a:lstStyle/>
-          <a:p>
-            <a:pPr algn="l"/>
-            <a:r>
-              <a:rPr sz="1800" b="1">
-                <a:solidFill>
-                  <a:srgbClr val="1E2732"/>
-                </a:solidFill>
-                <a:latin typeface="Aptos"/>
-              </a:rPr>
-              <a:t>Reviewer routing and recovery across 731 tasks</a:t>
-            </a:r>
-          </a:p>
-        </p:txBody>
-      </p:sp>
-      <p:sp>
-        <p:nvSpPr>
-          <p:cNvPr id="4" name="TextBox 3"/>
-          <p:cNvSpPr txBox="1"/>
-          <p:nvPr/>
-        </p:nvSpPr>
-        <p:spPr>
-          <a:xfrm>
-            <a:off x="338328" y="438912"/>
-            <a:ext cx="10149840" cy="201168"/>
-          </a:xfrm>
-          <a:prstGeom prst="rect">
-            <a:avLst/>
-          </a:prstGeom>
-          <a:noFill/>
-        </p:spPr>
-        <p:txBody>
-          <a:bodyPr wrap="none" lIns="18288" rIns="18288" tIns="9144" bIns="9144" anchor="ctr">
-            <a:spAutoFit/>
-          </a:bodyPr>
-          <a:lstStyle/>
-          <a:p>
-            <a:pPr algn="l"/>
-            <a:r>
-              <a:rPr sz="880" b="0">
-                <a:solidFill>
-                  <a:srgbClr val="5E6875"/>
-                </a:solidFill>
-                <a:latin typeface="Aptos"/>
-              </a:rPr>
-              <a:t>Mechanism analysis from accepted trajectories · adaptive routing, not randomized ablation</a:t>
-            </a:r>
-          </a:p>
-        </p:txBody>
-      </p:sp>
-      <p:sp>
-        <p:nvSpPr>
-          <p:cNvPr id="5" name="Rounded Rectangle 4"/>
+          <p:cNvPr id="4" name="Rounded Rectangle 3"/>
           <p:cNvSpPr/>
           <p:nvPr/>
         </p:nvSpPr>
         <p:spPr>
           <a:xfrm>
-            <a:off x="320040" y="749808"/>
-            <a:ext cx="3063240" cy="1956816"/>
+            <a:off x="320040" y="146304"/>
+            <a:ext cx="3063240" cy="1965960"/>
           </a:xfrm>
           <a:prstGeom prst="roundRect">
             <a:avLst/>
           </a:prstGeom>
           <a:solidFill>
-            <a:srgbClr val="F8FAFC"/>
+            <a:srgbClr val="FFFDF8"/>
           </a:solidFill>
           <a:ln w="10160">
             <a:solidFill>
@@ -3258,6 +3212,30 @@
           </a:p>
         </p:txBody>
       </p:sp>
+      <p:pic>
+        <p:nvPicPr>
+          <p:cNvPr id="5" name="Picture 4" descr="engineer.png"/>
+          <p:cNvPicPr>
+            <a:picLocks noChangeAspect="1"/>
+          </p:cNvPicPr>
+          <p:nvPr/>
+        </p:nvPicPr>
+        <p:blipFill>
+          <a:blip r:embed="rId3"/>
+          <a:stretch>
+            <a:fillRect/>
+          </a:stretch>
+        </p:blipFill>
+        <p:spPr>
+          <a:xfrm>
+            <a:off x="2697480" y="164592"/>
+            <a:ext cx="530352" cy="530352"/>
+          </a:xfrm>
+          <a:prstGeom prst="rect">
+            <a:avLst/>
+          </a:prstGeom>
+        </p:spPr>
+      </p:pic>
       <p:sp>
         <p:nvSpPr>
           <p:cNvPr id="6" name="TextBox 5"/>
@@ -3266,8 +3244,8 @@
         </p:nvSpPr>
         <p:spPr>
           <a:xfrm>
-            <a:off x="466344" y="822959"/>
-            <a:ext cx="2560320" cy="256032"/>
+            <a:off x="466344" y="219456"/>
+            <a:ext cx="2103120" cy="256032"/>
           </a:xfrm>
           <a:prstGeom prst="rect">
             <a:avLst/>
@@ -3286,9 +3264,9 @@
                 <a:solidFill>
                   <a:srgbClr val="173B70"/>
                 </a:solidFill>
-                <a:latin typeface="Aptos"/>
+                <a:latin typeface="Arial"/>
               </a:rPr>
-              <a:t>(a) Reviewer routing</a:t>
+              <a:t>(a) Routing</a:t>
             </a:r>
           </a:p>
         </p:txBody>
@@ -3301,14 +3279,14 @@
         </p:nvSpPr>
         <p:spPr>
           <a:xfrm>
-            <a:off x="484632" y="1280160"/>
+            <a:off x="484632" y="676656"/>
             <a:ext cx="2734056" cy="274320"/>
           </a:xfrm>
           <a:prstGeom prst="roundRect">
             <a:avLst/>
           </a:prstGeom>
           <a:solidFill>
-            <a:srgbClr val="FFFFFF"/>
+            <a:srgbClr val="FFFDF8"/>
           </a:solidFill>
           <a:ln w="10160">
             <a:solidFill>
@@ -3347,7 +3325,7 @@
         </p:nvSpPr>
         <p:spPr>
           <a:xfrm>
-            <a:off x="484632" y="1280160"/>
+            <a:off x="484632" y="676656"/>
             <a:ext cx="1742913" cy="274320"/>
           </a:xfrm>
           <a:prstGeom prst="roundRect">
@@ -3393,7 +3371,7 @@
         </p:nvSpPr>
         <p:spPr>
           <a:xfrm>
-            <a:off x="2227545" y="1280160"/>
+            <a:off x="2227545" y="676656"/>
             <a:ext cx="991142" cy="274320"/>
           </a:xfrm>
           <a:prstGeom prst="roundRect">
@@ -3439,7 +3417,7 @@
         </p:nvSpPr>
         <p:spPr>
           <a:xfrm>
-            <a:off x="539496" y="1280160"/>
+            <a:off x="539496" y="676656"/>
             <a:ext cx="1651473" cy="274320"/>
           </a:xfrm>
           <a:prstGeom prst="rect">
@@ -3457,9 +3435,9 @@
             <a:r>
               <a:rPr sz="919" b="1">
                 <a:solidFill>
-                  <a:srgbClr val="FFFFFF"/>
+                  <a:srgbClr val="FFFDF8"/>
                 </a:solidFill>
-                <a:latin typeface="Aptos"/>
+                <a:latin typeface="Arial"/>
               </a:rPr>
               <a:t>466 · 63.7%</a:t>
             </a:r>
@@ -3474,7 +3452,7 @@
         </p:nvSpPr>
         <p:spPr>
           <a:xfrm>
-            <a:off x="2227545" y="1280160"/>
+            <a:off x="2227545" y="676656"/>
             <a:ext cx="954566" cy="274320"/>
           </a:xfrm>
           <a:prstGeom prst="rect">
@@ -3492,9 +3470,9 @@
             <a:r>
               <a:rPr sz="860" b="1">
                 <a:solidFill>
-                  <a:srgbClr val="FFFFFF"/>
+                  <a:srgbClr val="FFFDF8"/>
                 </a:solidFill>
-                <a:latin typeface="Aptos"/>
+                <a:latin typeface="Arial"/>
               </a:rPr>
               <a:t>265 · 36.3%</a:t>
             </a:r>
@@ -3509,7 +3487,7 @@
         </p:nvSpPr>
         <p:spPr>
           <a:xfrm>
-            <a:off x="484632" y="1627631"/>
+            <a:off x="484632" y="1024128"/>
             <a:ext cx="1325880" cy="219456"/>
           </a:xfrm>
           <a:prstGeom prst="rect">
@@ -3525,13 +3503,13 @@
           <a:p>
             <a:pPr algn="l"/>
             <a:r>
-              <a:rPr sz="850" b="1">
+              <a:rPr sz="950" b="1">
                 <a:solidFill>
                   <a:srgbClr val="315BCE"/>
                 </a:solidFill>
-                <a:latin typeface="Aptos"/>
+                <a:latin typeface="Arial"/>
               </a:rPr>
-              <a:t>Independent Reviewer</a:t>
+              <a:t>Reviewer</a:t>
             </a:r>
           </a:p>
         </p:txBody>
@@ -3544,7 +3522,7 @@
         </p:nvSpPr>
         <p:spPr>
           <a:xfrm>
-            <a:off x="1965960" y="1627631"/>
+            <a:off x="1965960" y="1024128"/>
             <a:ext cx="1188720" cy="219456"/>
           </a:xfrm>
           <a:prstGeom prst="rect">
@@ -3560,13 +3538,13 @@
           <a:p>
             <a:pPr algn="r"/>
             <a:r>
-              <a:rPr sz="850" b="1">
+              <a:rPr sz="950" b="1">
                 <a:solidFill>
                   <a:srgbClr val="7A838E"/>
                 </a:solidFill>
-                <a:latin typeface="Aptos"/>
+                <a:latin typeface="Arial"/>
               </a:rPr>
-              <a:t>Engineer self-review</a:t>
+              <a:t>Self-review</a:t>
             </a:r>
           </a:p>
         </p:txBody>
@@ -3579,8 +3557,8 @@
         </p:nvSpPr>
         <p:spPr>
           <a:xfrm>
-            <a:off x="484632" y="1975104"/>
-            <a:ext cx="2734056" cy="201168"/>
+            <a:off x="484632" y="1572768"/>
+            <a:ext cx="2734056" cy="256032"/>
           </a:xfrm>
           <a:prstGeom prst="rect">
             <a:avLst/>
@@ -3595,68 +3573,33 @@
           <a:p>
             <a:pPr algn="ctr"/>
             <a:r>
-              <a:rPr sz="780" b="0">
-                <a:solidFill>
-                  <a:srgbClr val="5E6875"/>
-                </a:solidFill>
-                <a:latin typeface="Aptos"/>
-              </a:rPr>
-              <a:t>Reviewer routing selects the harder workload</a:t>
-            </a:r>
-          </a:p>
-        </p:txBody>
-      </p:sp>
-      <p:sp>
-        <p:nvSpPr>
-          <p:cNvPr id="15" name="TextBox 14"/>
-          <p:cNvSpPr txBox="1"/>
-          <p:nvPr/>
-        </p:nvSpPr>
-        <p:spPr>
-          <a:xfrm>
-            <a:off x="484632" y="2194560"/>
-            <a:ext cx="2734056" cy="219456"/>
-          </a:xfrm>
-          <a:prstGeom prst="rect">
-            <a:avLst/>
-          </a:prstGeom>
-          <a:noFill/>
-        </p:spPr>
-        <p:txBody>
-          <a:bodyPr wrap="none" lIns="18288" rIns="18288" tIns="9144" bIns="9144" anchor="ctr">
-            <a:spAutoFit/>
-          </a:bodyPr>
-          <a:lstStyle/>
-          <a:p>
-            <a:pPr algn="ctr"/>
-            <a:r>
-              <a:rPr sz="919" b="1">
+              <a:rPr sz="1100" b="1">
                 <a:solidFill>
                   <a:srgbClr val="173B70"/>
                 </a:solidFill>
-                <a:latin typeface="Aptos"/>
+                <a:latin typeface="Arial"/>
               </a:rPr>
-              <a:t>2.75× Token · 1.80× active time</a:t>
-            </a:r>
-          </a:p>
-        </p:txBody>
-      </p:sp>
-      <p:sp>
-        <p:nvSpPr>
-          <p:cNvPr id="16" name="Rounded Rectangle 15"/>
+              <a:t>2.75× tokens · 1.80× time</a:t>
+            </a:r>
+          </a:p>
+        </p:txBody>
+      </p:sp>
+      <p:sp>
+        <p:nvSpPr>
+          <p:cNvPr id="15" name="Rounded Rectangle 14"/>
           <p:cNvSpPr/>
           <p:nvPr/>
         </p:nvSpPr>
         <p:spPr>
           <a:xfrm>
-            <a:off x="3584448" y="749808"/>
-            <a:ext cx="7068312" cy="1956816"/>
+            <a:off x="3584448" y="146304"/>
+            <a:ext cx="7068312" cy="1965960"/>
           </a:xfrm>
           <a:prstGeom prst="roundRect">
             <a:avLst/>
           </a:prstGeom>
           <a:solidFill>
-            <a:srgbClr val="FFFFFF"/>
+            <a:srgbClr val="FFFDF8"/>
           </a:solidFill>
           <a:ln w="10160">
             <a:solidFill>
@@ -3687,6 +3630,30 @@
           </a:p>
         </p:txBody>
       </p:sp>
+      <p:pic>
+        <p:nvPicPr>
+          <p:cNvPr id="16" name="Picture 15" descr="reviewer.png"/>
+          <p:cNvPicPr>
+            <a:picLocks noChangeAspect="1"/>
+          </p:cNvPicPr>
+          <p:nvPr/>
+        </p:nvPicPr>
+        <p:blipFill>
+          <a:blip r:embed="rId4"/>
+          <a:stretch>
+            <a:fillRect/>
+          </a:stretch>
+        </p:blipFill>
+        <p:spPr>
+          <a:xfrm>
+            <a:off x="9921240" y="164592"/>
+            <a:ext cx="530352" cy="530352"/>
+          </a:xfrm>
+          <a:prstGeom prst="rect">
+            <a:avLst/>
+          </a:prstGeom>
+        </p:spPr>
+      </p:pic>
       <p:sp>
         <p:nvSpPr>
           <p:cNvPr id="17" name="TextBox 16"/>
@@ -3695,7 +3662,7 @@
         </p:nvSpPr>
         <p:spPr>
           <a:xfrm>
-            <a:off x="3730752" y="822959"/>
+            <a:off x="3730752" y="219456"/>
             <a:ext cx="4754880" cy="256032"/>
           </a:xfrm>
           <a:prstGeom prst="rect">
@@ -3715,9 +3682,9 @@
                 <a:solidFill>
                   <a:srgbClr val="173B70"/>
                 </a:solidFill>
-                <a:latin typeface="Aptos"/>
+                <a:latin typeface="Arial"/>
               </a:rPr>
-              <a:t>(b) Reviewer intervention and recovery</a:t>
+              <a:t>(b) Revision recovery</a:t>
             </a:r>
           </a:p>
         </p:txBody>
@@ -3730,7 +3697,7 @@
         </p:nvSpPr>
         <p:spPr>
           <a:xfrm>
-            <a:off x="3749039" y="1298448"/>
+            <a:off x="3749039" y="694944"/>
             <a:ext cx="1188720" cy="932688"/>
           </a:xfrm>
           <a:prstGeom prst="roundRect">
@@ -3776,7 +3743,7 @@
         </p:nvSpPr>
         <p:spPr>
           <a:xfrm>
-            <a:off x="3840479" y="1371600"/>
+            <a:off x="3840479" y="768096"/>
             <a:ext cx="1005840" cy="438363"/>
           </a:xfrm>
           <a:prstGeom prst="rect">
@@ -3796,7 +3763,7 @@
                 <a:solidFill>
                   <a:srgbClr val="173B70"/>
                 </a:solidFill>
-                <a:latin typeface="Aptos"/>
+                <a:latin typeface="Arial"/>
               </a:rPr>
               <a:t>466</a:t>
             </a:r>
@@ -3811,7 +3778,7 @@
         </p:nvSpPr>
         <p:spPr>
           <a:xfrm>
-            <a:off x="3840479" y="1783445"/>
+            <a:off x="3840479" y="1179941"/>
             <a:ext cx="1005840" cy="326440"/>
           </a:xfrm>
           <a:prstGeom prst="rect">
@@ -3827,13 +3794,13 @@
           <a:p>
             <a:pPr algn="ctr"/>
             <a:r>
-              <a:rPr sz="830" b="0">
+              <a:rPr sz="930" b="0">
                 <a:solidFill>
-                  <a:srgbClr val="5E6875"/>
+                  <a:srgbClr val="66717D"/>
                 </a:solidFill>
-                <a:latin typeface="Aptos"/>
+                <a:latin typeface="Arial"/>
               </a:rPr>
-              <a:t>Reviewer-invoked tasks</a:t>
+              <a:t>Invoked</a:t>
             </a:r>
           </a:p>
         </p:txBody>
@@ -3846,7 +3813,7 @@
         </p:nvCxnSpPr>
         <p:spPr>
           <a:xfrm flipV="1">
-            <a:off x="4974336" y="1444752"/>
+            <a:off x="4974336" y="841248"/>
             <a:ext cx="457200" cy="310896"/>
           </a:xfrm>
           <a:prstGeom prst="line">
@@ -3881,7 +3848,7 @@
         </p:nvCxnSpPr>
         <p:spPr>
           <a:xfrm>
-            <a:off x="4974336" y="1755648"/>
+            <a:off x="4974336" y="1152144"/>
             <a:ext cx="457200" cy="420624"/>
           </a:xfrm>
           <a:prstGeom prst="line">
@@ -3916,7 +3883,7 @@
         </p:nvSpPr>
         <p:spPr>
           <a:xfrm>
-            <a:off x="5468112" y="1115568"/>
+            <a:off x="5468112" y="512064"/>
             <a:ext cx="1207008" cy="603504"/>
           </a:xfrm>
           <a:prstGeom prst="roundRect">
@@ -3962,7 +3929,7 @@
         </p:nvSpPr>
         <p:spPr>
           <a:xfrm>
-            <a:off x="5559552" y="1188720"/>
+            <a:off x="5559552" y="585216"/>
             <a:ext cx="1024128" cy="283646"/>
           </a:xfrm>
           <a:prstGeom prst="rect">
@@ -3982,7 +3949,7 @@
                 <a:solidFill>
                   <a:srgbClr val="173B70"/>
                 </a:solidFill>
-                <a:latin typeface="Aptos"/>
+                <a:latin typeface="Arial"/>
               </a:rPr>
               <a:t>388</a:t>
             </a:r>
@@ -3997,7 +3964,7 @@
         </p:nvSpPr>
         <p:spPr>
           <a:xfrm>
-            <a:off x="5559552" y="1429390"/>
+            <a:off x="5559552" y="825886"/>
             <a:ext cx="1024128" cy="211226"/>
           </a:xfrm>
           <a:prstGeom prst="rect">
@@ -4013,13 +3980,13 @@
           <a:p>
             <a:pPr algn="ctr"/>
             <a:r>
-              <a:rPr sz="830" b="0">
+              <a:rPr sz="930" b="0">
                 <a:solidFill>
-                  <a:srgbClr val="5E6875"/>
+                  <a:srgbClr val="66717D"/>
                 </a:solidFill>
-                <a:latin typeface="Aptos"/>
+                <a:latin typeface="Arial"/>
               </a:rPr>
-              <a:t>accepted first review</a:t>
+              <a:t>Accepted</a:t>
             </a:r>
           </a:p>
         </p:txBody>
@@ -4032,7 +3999,7 @@
         </p:nvSpPr>
         <p:spPr>
           <a:xfrm>
-            <a:off x="5468112" y="1883664"/>
+            <a:off x="5468112" y="1280160"/>
             <a:ext cx="1207008" cy="603504"/>
           </a:xfrm>
           <a:prstGeom prst="roundRect">
@@ -4078,7 +4045,7 @@
         </p:nvSpPr>
         <p:spPr>
           <a:xfrm>
-            <a:off x="5559552" y="1956816"/>
+            <a:off x="5559552" y="1353312"/>
             <a:ext cx="1024128" cy="283646"/>
           </a:xfrm>
           <a:prstGeom prst="rect">
@@ -4098,7 +4065,7 @@
                 <a:solidFill>
                   <a:srgbClr val="C38A20"/>
                 </a:solidFill>
-                <a:latin typeface="Aptos"/>
+                <a:latin typeface="Arial"/>
               </a:rPr>
               <a:t>43</a:t>
             </a:r>
@@ -4113,7 +4080,7 @@
         </p:nvSpPr>
         <p:spPr>
           <a:xfrm>
-            <a:off x="5559552" y="2197486"/>
+            <a:off x="5559552" y="1593982"/>
             <a:ext cx="1024128" cy="211226"/>
           </a:xfrm>
           <a:prstGeom prst="rect">
@@ -4129,61 +4096,26 @@
           <a:p>
             <a:pPr algn="ctr"/>
             <a:r>
-              <a:rPr sz="830" b="0">
+              <a:rPr sz="930" b="0">
                 <a:solidFill>
-                  <a:srgbClr val="5E6875"/>
+                  <a:srgbClr val="66717D"/>
                 </a:solidFill>
-                <a:latin typeface="Aptos"/>
+                <a:latin typeface="Arial"/>
               </a:rPr>
-              <a:t>revision requested</a:t>
-            </a:r>
-          </a:p>
-        </p:txBody>
-      </p:sp>
-      <p:sp>
-        <p:nvSpPr>
-          <p:cNvPr id="29" name="TextBox 28"/>
-          <p:cNvSpPr txBox="1"/>
-          <p:nvPr/>
-        </p:nvSpPr>
-        <p:spPr>
-          <a:xfrm>
-            <a:off x="3730752" y="2359152"/>
-            <a:ext cx="1335024" cy="164592"/>
-          </a:xfrm>
-          <a:prstGeom prst="rect">
-            <a:avLst/>
-          </a:prstGeom>
-          <a:noFill/>
-        </p:spPr>
-        <p:txBody>
-          <a:bodyPr wrap="none" lIns="18288" rIns="18288" tIns="9144" bIns="9144" anchor="ctr">
-            <a:spAutoFit/>
-          </a:bodyPr>
-          <a:lstStyle/>
-          <a:p>
-            <a:pPr algn="ctr"/>
-            <a:r>
-              <a:rPr sz="690" b="0">
-                <a:solidFill>
-                  <a:srgbClr val="7A838E"/>
-                </a:solidFill>
-                <a:latin typeface="Aptos"/>
-              </a:rPr>
-              <a:t>35 blocked without a revision loop</a:t>
+              <a:t>Revise</a:t>
             </a:r>
           </a:p>
         </p:txBody>
       </p:sp>
       <p:cxnSp>
         <p:nvCxnSpPr>
-          <p:cNvPr id="30" name="Connector 29"/>
+          <p:cNvPr id="29" name="Connector 28"/>
           <p:cNvCxnSpPr/>
           <p:nvPr/>
         </p:nvCxnSpPr>
         <p:spPr>
           <a:xfrm>
-            <a:off x="6711696" y="2185416"/>
+            <a:off x="6711696" y="1581912"/>
             <a:ext cx="457200" cy="0"/>
           </a:xfrm>
           <a:prstGeom prst="line">
@@ -4212,13 +4144,13 @@
       </p:cxnSp>
       <p:sp>
         <p:nvSpPr>
-          <p:cNvPr id="31" name="Rounded Rectangle 30"/>
+          <p:cNvPr id="30" name="Rounded Rectangle 29"/>
           <p:cNvSpPr/>
           <p:nvPr/>
         </p:nvSpPr>
         <p:spPr>
           <a:xfrm>
-            <a:off x="7205472" y="1883664"/>
+            <a:off x="7205472" y="1280160"/>
             <a:ext cx="1298448" cy="603504"/>
           </a:xfrm>
           <a:prstGeom prst="roundRect">
@@ -4258,13 +4190,13 @@
       </p:sp>
       <p:sp>
         <p:nvSpPr>
-          <p:cNvPr id="32" name="TextBox 31"/>
+          <p:cNvPr id="31" name="TextBox 30"/>
           <p:cNvSpPr txBox="1"/>
           <p:nvPr/>
         </p:nvSpPr>
         <p:spPr>
           <a:xfrm>
-            <a:off x="7296912" y="1956816"/>
+            <a:off x="7296912" y="1353312"/>
             <a:ext cx="1115568" cy="283646"/>
           </a:xfrm>
           <a:prstGeom prst="rect">
@@ -4284,7 +4216,7 @@
                 <a:solidFill>
                   <a:srgbClr val="173B70"/>
                 </a:solidFill>
-                <a:latin typeface="Aptos"/>
+                <a:latin typeface="Arial"/>
               </a:rPr>
               <a:t>34</a:t>
             </a:r>
@@ -4293,13 +4225,13 @@
       </p:sp>
       <p:sp>
         <p:nvSpPr>
-          <p:cNvPr id="33" name="TextBox 32"/>
+          <p:cNvPr id="32" name="TextBox 31"/>
           <p:cNvSpPr txBox="1"/>
           <p:nvPr/>
         </p:nvSpPr>
         <p:spPr>
           <a:xfrm>
-            <a:off x="7296912" y="2197486"/>
+            <a:off x="7296912" y="1593982"/>
             <a:ext cx="1115568" cy="211226"/>
           </a:xfrm>
           <a:prstGeom prst="rect">
@@ -4315,26 +4247,26 @@
           <a:p>
             <a:pPr algn="ctr"/>
             <a:r>
-              <a:rPr sz="830" b="0">
+              <a:rPr sz="930" b="0">
                 <a:solidFill>
-                  <a:srgbClr val="5E6875"/>
+                  <a:srgbClr val="66717D"/>
                 </a:solidFill>
-                <a:latin typeface="Aptos"/>
+                <a:latin typeface="Arial"/>
               </a:rPr>
-              <a:t>passed official verifier</a:t>
+              <a:t>Verifier pass</a:t>
             </a:r>
           </a:p>
         </p:txBody>
       </p:sp>
       <p:cxnSp>
         <p:nvCxnSpPr>
-          <p:cNvPr id="34" name="Connector 33"/>
+          <p:cNvPr id="33" name="Connector 32"/>
           <p:cNvCxnSpPr/>
           <p:nvPr/>
         </p:nvCxnSpPr>
         <p:spPr>
           <a:xfrm>
-            <a:off x="8540496" y="2185416"/>
+            <a:off x="8540496" y="1581912"/>
             <a:ext cx="420624" cy="0"/>
           </a:xfrm>
           <a:prstGeom prst="line">
@@ -4363,13 +4295,13 @@
       </p:cxnSp>
       <p:sp>
         <p:nvSpPr>
-          <p:cNvPr id="35" name="Rounded Rectangle 34"/>
+          <p:cNvPr id="34" name="Rounded Rectangle 33"/>
           <p:cNvSpPr/>
           <p:nvPr/>
         </p:nvSpPr>
         <p:spPr>
           <a:xfrm>
-            <a:off x="8997696" y="1883664"/>
+            <a:off x="8997696" y="1280160"/>
             <a:ext cx="1335024" cy="603504"/>
           </a:xfrm>
           <a:prstGeom prst="roundRect">
@@ -4409,13 +4341,13 @@
       </p:sp>
       <p:sp>
         <p:nvSpPr>
-          <p:cNvPr id="36" name="TextBox 35"/>
+          <p:cNvPr id="35" name="TextBox 34"/>
           <p:cNvSpPr txBox="1"/>
           <p:nvPr/>
         </p:nvSpPr>
         <p:spPr>
           <a:xfrm>
-            <a:off x="9089136" y="1956816"/>
+            <a:off x="9089136" y="1353312"/>
             <a:ext cx="1152144" cy="283646"/>
           </a:xfrm>
           <a:prstGeom prst="rect">
@@ -4435,7 +4367,7 @@
                 <a:solidFill>
                   <a:srgbClr val="C38A20"/>
                 </a:solidFill>
-                <a:latin typeface="Aptos"/>
+                <a:latin typeface="Arial"/>
               </a:rPr>
               <a:t>22</a:t>
             </a:r>
@@ -4444,13 +4376,13 @@
       </p:sp>
       <p:sp>
         <p:nvSpPr>
-          <p:cNvPr id="37" name="TextBox 36"/>
+          <p:cNvPr id="36" name="TextBox 35"/>
           <p:cNvSpPr txBox="1"/>
           <p:nvPr/>
         </p:nvSpPr>
         <p:spPr>
           <a:xfrm>
-            <a:off x="9089136" y="2197486"/>
+            <a:off x="9089136" y="1593982"/>
             <a:ext cx="1152144" cy="211226"/>
           </a:xfrm>
           <a:prstGeom prst="rect">
@@ -4466,83 +4398,13 @@
           <a:p>
             <a:pPr algn="ctr"/>
             <a:r>
-              <a:rPr sz="830" b="0">
+              <a:rPr sz="930" b="0">
                 <a:solidFill>
-                  <a:srgbClr val="5E6875"/>
+                  <a:srgbClr val="66717D"/>
                 </a:solidFill>
-                <a:latin typeface="Aptos"/>
+                <a:latin typeface="Arial"/>
               </a:rPr>
-              <a:t>strict Reviewer rescues</a:t>
-            </a:r>
-          </a:p>
-        </p:txBody>
-      </p:sp>
-      <p:sp>
-        <p:nvSpPr>
-          <p:cNvPr id="38" name="TextBox 37"/>
-          <p:cNvSpPr txBox="1"/>
-          <p:nvPr/>
-        </p:nvSpPr>
-        <p:spPr>
-          <a:xfrm>
-            <a:off x="6986016" y="2523744"/>
-            <a:ext cx="3383280" cy="164592"/>
-          </a:xfrm>
-          <a:prstGeom prst="rect">
-            <a:avLst/>
-          </a:prstGeom>
-          <a:noFill/>
-        </p:spPr>
-        <p:txBody>
-          <a:bodyPr wrap="none" lIns="18288" rIns="18288" tIns="9144" bIns="9144" anchor="ctr">
-            <a:spAutoFit/>
-          </a:bodyPr>
-          <a:lstStyle/>
-          <a:p>
-            <a:pPr algn="r"/>
-            <a:r>
-              <a:rPr sz="710" b="0">
-                <a:solidFill>
-                  <a:srgbClr val="5E6875"/>
-                </a:solidFill>
-                <a:latin typeface="Aptos"/>
-              </a:rPr>
-              <a:t>Strict rescue: Reviewer continue → Engineer revision → later Reviewer done</a:t>
-            </a:r>
-          </a:p>
-        </p:txBody>
-      </p:sp>
-      <p:sp>
-        <p:nvSpPr>
-          <p:cNvPr id="39" name="TextBox 38"/>
-          <p:cNvSpPr txBox="1"/>
-          <p:nvPr/>
-        </p:nvSpPr>
-        <p:spPr>
-          <a:xfrm>
-            <a:off x="347472" y="2779776"/>
-            <a:ext cx="10241280" cy="164592"/>
-          </a:xfrm>
-          <a:prstGeom prst="rect">
-            <a:avLst/>
-          </a:prstGeom>
-          <a:noFill/>
-        </p:spPr>
-        <p:txBody>
-          <a:bodyPr wrap="none" lIns="18288" rIns="18288" tIns="9144" bIns="9144" anchor="ctr">
-            <a:spAutoFit/>
-          </a:bodyPr>
-          <a:lstStyle/>
-          <a:p>
-            <a:pPr algn="ctr"/>
-            <a:r>
-              <a:rPr sz="730" b="0">
-                <a:solidFill>
-                  <a:srgbClr val="5E6875"/>
-                </a:solidFill>
-                <a:latin typeface="Aptos"/>
-              </a:rPr>
-              <a:t>Group-level accuracy is intentionally omitted: Reviewer routing is conditional on task difficulty.</a:t>
+              <a:t>Strict rescue</a:t>
             </a:r>
           </a:p>
         </p:txBody>

</xml_diff>